<commit_message>
feat: add interactive VS Code query runner run_in_vscode.py and sync presentation metrics
</commit_message>
<xml_diff>
--- a/final_submission/Grocery_Store_Management.pptx
+++ b/final_submission/Grocery_Store_Management.pptx
@@ -8847,7 +8847,7 @@
                         </a:defRPr>
                       </a:pPr>
                       <a:r>
-                        <a:t>Jyotika (165)</a:t>
+                        <a:t>Chetan Naidu (19)</a:t>
                       </a:r>
                     </a:p>
                   </a:txBody>
@@ -8870,7 +8870,7 @@
                         </a:defRPr>
                       </a:pPr>
                       <a:r>
-                        <a:t>7</a:t>
+                        <a:t>4</a:t>
                       </a:r>
                     </a:p>
                   </a:txBody>
@@ -8893,7 +8893,7 @@
                         </a:defRPr>
                       </a:pPr>
                       <a:r>
-                        <a:t>₹16,914.88</a:t>
+                        <a:t>₹11,256.81</a:t>
                       </a:r>
                     </a:p>
                   </a:txBody>
@@ -8916,7 +8916,7 @@
                         </a:defRPr>
                       </a:pPr>
                       <a:r>
-                        <a:t>₹2,416.41</a:t>
+                        <a:t>₹2,814.20</a:t>
                       </a:r>
                     </a:p>
                   </a:txBody>
@@ -8941,7 +8941,7 @@
                         </a:defRPr>
                       </a:pPr>
                       <a:r>
-                        <a:t>Chetan Rao (145)</a:t>
+                        <a:t>Kapila (166)</a:t>
                       </a:r>
                     </a:p>
                   </a:txBody>
@@ -8964,7 +8964,7 @@
                         </a:defRPr>
                       </a:pPr>
                       <a:r>
-                        <a:t>5</a:t>
+                        <a:t>4</a:t>
                       </a:r>
                     </a:p>
                   </a:txBody>
@@ -8987,7 +8987,7 @@
                         </a:defRPr>
                       </a:pPr>
                       <a:r>
-                        <a:t>₹13,446.54</a:t>
+                        <a:t>₹11,099.52</a:t>
                       </a:r>
                     </a:p>
                   </a:txBody>
@@ -9010,7 +9010,7 @@
                         </a:defRPr>
                       </a:pPr>
                       <a:r>
-                        <a:t>₹2,689.31</a:t>
+                        <a:t>₹2,774.88</a:t>
                       </a:r>
                     </a:p>
                   </a:txBody>
@@ -9035,7 +9035,7 @@
                         </a:defRPr>
                       </a:pPr>
                       <a:r>
-                        <a:t>Eshwar Menon (32)</a:t>
+                        <a:t>Eshwar Rao (67)</a:t>
                       </a:r>
                     </a:p>
                   </a:txBody>
@@ -9058,7 +9058,7 @@
                         </a:defRPr>
                       </a:pPr>
                       <a:r>
-                        <a:t>5</a:t>
+                        <a:t>3</a:t>
                       </a:r>
                     </a:p>
                   </a:txBody>
@@ -9081,7 +9081,7 @@
                         </a:defRPr>
                       </a:pPr>
                       <a:r>
-                        <a:t>₹13,293.45</a:t>
+                        <a:t>₹10,819.97</a:t>
                       </a:r>
                     </a:p>
                   </a:txBody>
@@ -9104,7 +9104,7 @@
                         </a:defRPr>
                       </a:pPr>
                       <a:r>
-                        <a:t>₹2,658.69</a:t>
+                        <a:t>₹3,606.66</a:t>
                       </a:r>
                     </a:p>
                   </a:txBody>
@@ -9129,7 +9129,7 @@
                         </a:defRPr>
                       </a:pPr>
                       <a:r>
-                        <a:t>Hari Naidu (128)</a:t>
+                        <a:t>Aditi Rao (61)</a:t>
                       </a:r>
                     </a:p>
                   </a:txBody>
@@ -9152,7 +9152,7 @@
                         </a:defRPr>
                       </a:pPr>
                       <a:r>
-                        <a:t>5</a:t>
+                        <a:t>4</a:t>
                       </a:r>
                     </a:p>
                   </a:txBody>
@@ -9175,7 +9175,7 @@
                         </a:defRPr>
                       </a:pPr>
                       <a:r>
-                        <a:t>₹12,987.97</a:t>
+                        <a:t>₹10,230.65</a:t>
                       </a:r>
                     </a:p>
                   </a:txBody>
@@ -9198,7 +9198,7 @@
                         </a:defRPr>
                       </a:pPr>
                       <a:r>
-                        <a:t>₹2,597.59</a:t>
+                        <a:t>₹2,557.66</a:t>
                       </a:r>
                     </a:p>
                   </a:txBody>
@@ -9223,7 +9223,7 @@
                         </a:defRPr>
                       </a:pPr>
                       <a:r>
-                        <a:t>Chetan Naidu (19)</a:t>
+                        <a:t>Eshwar Iyer (7)</a:t>
                       </a:r>
                     </a:p>
                   </a:txBody>
@@ -9246,7 +9246,7 @@
                         </a:defRPr>
                       </a:pPr>
                       <a:r>
-                        <a:t>5</a:t>
+                        <a:t>4</a:t>
                       </a:r>
                     </a:p>
                   </a:txBody>
@@ -9269,7 +9269,7 @@
                         </a:defRPr>
                       </a:pPr>
                       <a:r>
-                        <a:t>₹12,677.30</a:t>
+                        <a:t>₹9,188.46</a:t>
                       </a:r>
                     </a:p>
                   </a:txBody>
@@ -9292,7 +9292,7 @@
                         </a:defRPr>
                       </a:pPr>
                       <a:r>
-                        <a:t>₹2,535.46</a:t>
+                        <a:t>₹2,297.11</a:t>
                       </a:r>
                     </a:p>
                   </a:txBody>
@@ -9352,7 +9352,7 @@
               </a:defRPr>
             </a:pPr>
             <a:r>
-              <a:t>The top 5 shoppers generated ₹69,320.14 (12.57% of total revenue) across 27 orders with an exceptional average AOV of ₹2,567.41.</a:t>
+              <a:t>The top 5 shoppers generated ₹52,595.41 (9.54% of total revenue) across 19 orders with an exceptional average AOV of ₹2,768.18.</a:t>
             </a:r>
           </a:p>
         </p:txBody>

</xml_diff>